<commit_message>
Switch to JSON file storage — no database setup needed
</commit_message>
<xml_diff>
--- a/ROADSoS_Presentation.pptx
+++ b/ROADSoS_Presentation.pptx
@@ -5475,8 +5475,8 @@
         </p:nvSpPr>
         <p:spPr>
           <a:xfrm>
-            <a:off x="1005840" y="1783080"/>
-            <a:ext cx="2834640" cy="1463040"/>
+            <a:off x="1005840" y="1920240"/>
+            <a:ext cx="2834640" cy="1325880"/>
           </a:xfrm>
           <a:prstGeom prst="rect">
             <a:avLst/>
@@ -5970,6 +5970,7 @@
               </a:defRPr>
             </a:pPr>
             <a:r>
+              <a:rPr dirty="0"/>
               <a:t>⚙️  Backend (Node.js + Express)</a:t>
             </a:r>
           </a:p>
@@ -5983,8 +5984,8 @@
         </p:nvSpPr>
         <p:spPr>
           <a:xfrm>
-            <a:off x="1005840" y="4526280"/>
-            <a:ext cx="3200400" cy="731520"/>
+            <a:off x="1005840" y="4590288"/>
+            <a:ext cx="3200400" cy="667512"/>
           </a:xfrm>
           <a:prstGeom prst="rect">
             <a:avLst/>
@@ -6050,6 +6051,7 @@
               </a:defRPr>
             </a:pPr>
             <a:r>
+              <a:rPr dirty="0"/>
               <a:t>🏥 Auth Service</a:t>
             </a:r>
           </a:p>
@@ -6086,7 +6088,16 @@
               </a:defRPr>
             </a:pPr>
             <a:r>
-              <a:t>JWT, bcrypt, OTP, register, login, password reset</a:t>
+              <a:rPr dirty="0"/>
+              <a:t>JWT, </a:t>
+            </a:r>
+            <a:r>
+              <a:rPr dirty="0" err="1"/>
+              <a:t>bcrypt</a:t>
+            </a:r>
+            <a:r>
+              <a:rPr dirty="0"/>
+              <a:t>, OTP, register, login, password reset</a:t>
             </a:r>
           </a:p>
         </p:txBody>

</xml_diff>